<commit_message>
Update session 6 contents
</commit_message>
<xml_diff>
--- a/lectures/Session_06_ANOVA_Regression/slides/Session 6_ ANOVA and Linear Regression.pptx
+++ b/lectures/Session_06_ANOVA_Regression/slides/Session 6_ ANOVA and Linear Regression.pptx
@@ -945,8 +945,8 @@
         </p:nvSpPr>
         <p:spPr>
           <a:xfrm>
-            <a:off x="1143225" y="685800"/>
-            <a:ext cx="4572225" cy="3429000"/>
+            <a:off x="381000" y="685800"/>
+            <a:ext cx="6096000" cy="3429000"/>
           </a:xfrm>
           <a:custGeom>
             <a:avLst/>
@@ -1465,8 +1465,8 @@
         </p:nvSpPr>
         <p:spPr>
           <a:xfrm>
-            <a:off x="1143225" y="685800"/>
-            <a:ext cx="4572225" cy="3429000"/>
+            <a:off x="381000" y="685800"/>
+            <a:ext cx="6096000" cy="3429000"/>
           </a:xfrm>
           <a:custGeom>
             <a:avLst/>
@@ -2297,8 +2297,8 @@
         </p:nvSpPr>
         <p:spPr>
           <a:xfrm>
-            <a:off x="1143225" y="685800"/>
-            <a:ext cx="4572225" cy="3429000"/>
+            <a:off x="381000" y="685800"/>
+            <a:ext cx="6096000" cy="3429000"/>
           </a:xfrm>
           <a:custGeom>
             <a:avLst/>
@@ -2609,8 +2609,8 @@
         </p:nvSpPr>
         <p:spPr>
           <a:xfrm>
-            <a:off x="1143225" y="685800"/>
-            <a:ext cx="4572225" cy="3429000"/>
+            <a:off x="381000" y="685800"/>
+            <a:ext cx="6096000" cy="3429000"/>
           </a:xfrm>
           <a:custGeom>
             <a:avLst/>
@@ -2713,8 +2713,8 @@
         </p:nvSpPr>
         <p:spPr>
           <a:xfrm>
-            <a:off x="1143225" y="685800"/>
-            <a:ext cx="4572225" cy="3429000"/>
+            <a:off x="381000" y="685800"/>
+            <a:ext cx="6096000" cy="3429000"/>
           </a:xfrm>
           <a:custGeom>
             <a:avLst/>
@@ -3337,8 +3337,8 @@
         </p:nvSpPr>
         <p:spPr>
           <a:xfrm>
-            <a:off x="1143225" y="685800"/>
-            <a:ext cx="4572225" cy="3429000"/>
+            <a:off x="381000" y="685800"/>
+            <a:ext cx="6096000" cy="3429000"/>
           </a:xfrm>
           <a:custGeom>
             <a:avLst/>
@@ -5313,8 +5313,8 @@
         </p:nvSpPr>
         <p:spPr>
           <a:xfrm>
-            <a:off x="1143225" y="685800"/>
-            <a:ext cx="4572225" cy="3429000"/>
+            <a:off x="381000" y="685800"/>
+            <a:ext cx="6096000" cy="3429000"/>
           </a:xfrm>
           <a:custGeom>
             <a:avLst/>
@@ -15695,7 +15695,7 @@
               <a:buNone/>
             </a:pPr>
             <a:r>
-              <a:rPr lang="en-US" sz="1350" b="1" i="0" u="none" strike="noStrike" cap="none">
+              <a:rPr lang="en-US" sz="1350" b="1" i="0" u="none" strike="noStrike" cap="none" dirty="0">
                 <a:solidFill>
                   <a:srgbClr val="334155"/>
                 </a:solidFill>
@@ -15707,7 +15707,7 @@
               <a:t>Instructor:</a:t>
             </a:r>
             <a:r>
-              <a:rPr lang="en-US" sz="1350" b="0" i="0" u="none" strike="noStrike" cap="none">
+              <a:rPr lang="en-US" sz="1350" b="0" i="0" u="none" strike="noStrike" cap="none" dirty="0">
                 <a:solidFill>
                   <a:srgbClr val="334155"/>
                 </a:solidFill>
@@ -15719,7 +15719,7 @@
               <a:t> Dr. Haogao Gu | </a:t>
             </a:r>
             <a:r>
-              <a:rPr lang="en-US" sz="1350" b="1" i="0" u="none" strike="noStrike" cap="none">
+              <a:rPr lang="en-US" sz="1350" b="1" i="0" u="none" strike="noStrike" cap="none" dirty="0">
                 <a:solidFill>
                   <a:srgbClr val="334155"/>
                 </a:solidFill>
@@ -15731,7 +15731,7 @@
               <a:t>Date:</a:t>
             </a:r>
             <a:r>
-              <a:rPr lang="en-US" sz="1350" b="0" i="0" u="none" strike="noStrike" cap="none">
+              <a:rPr lang="en-US" sz="1350" b="0" i="0" u="none" strike="noStrike" cap="none" dirty="0">
                 <a:solidFill>
                   <a:srgbClr val="334155"/>
                 </a:solidFill>
@@ -15742,7 +15742,67 @@
               </a:rPr>
               <a:t> January 21, 2026</a:t>
             </a:r>
-            <a:endParaRPr/>
+            <a:endParaRPr dirty="0"/>
+          </a:p>
+        </p:txBody>
+      </p:sp>
+      <p:sp>
+        <p:nvSpPr>
+          <p:cNvPr id="2" name="Google Shape;88;p13">
+            <a:extLst>
+              <a:ext uri="{FF2B5EF4-FFF2-40B4-BE49-F238E27FC236}">
+                <a16:creationId xmlns:a16="http://schemas.microsoft.com/office/drawing/2014/main" id="{2AA4AE38-D79A-58F7-CF85-0B1E1F95C909}"/>
+              </a:ext>
+            </a:extLst>
+          </p:cNvPr>
+          <p:cNvSpPr txBox="1"/>
+          <p:nvPr/>
+        </p:nvSpPr>
+        <p:spPr>
+          <a:xfrm>
+            <a:off x="1" y="5899412"/>
+            <a:ext cx="3193366" cy="323165"/>
+          </a:xfrm>
+          <a:prstGeom prst="rect">
+            <a:avLst/>
+          </a:prstGeom>
+          <a:noFill/>
+          <a:ln>
+            <a:noFill/>
+          </a:ln>
+        </p:spPr>
+        <p:txBody>
+          <a:bodyPr spcFirstLastPara="1" wrap="square" lIns="0" tIns="0" rIns="0" bIns="0" anchor="t" anchorCtr="0">
+            <a:spAutoFit/>
+          </a:bodyPr>
+          <a:lstStyle/>
+          <a:p>
+            <a:pPr marL="0" marR="0" lvl="0" indent="0" algn="ctr" rtl="0">
+              <a:spcBef>
+                <a:spcPts val="0"/>
+              </a:spcBef>
+              <a:spcAft>
+                <a:spcPts val="0"/>
+              </a:spcAft>
+              <a:buNone/>
+            </a:pPr>
+            <a:r>
+              <a:rPr lang="en-US" sz="2100" b="0" i="0" u="none" strike="noStrike" cap="none" dirty="0">
+                <a:solidFill>
+                  <a:srgbClr val="FF0000"/>
+                </a:solidFill>
+                <a:latin typeface="Lato Light"/>
+                <a:ea typeface="Lato Light"/>
+                <a:cs typeface="Lato Light"/>
+                <a:sym typeface="Lato Light"/>
+              </a:rPr>
+              <a:t>Updated on January 21</a:t>
+            </a:r>
+            <a:endParaRPr dirty="0">
+              <a:solidFill>
+                <a:srgbClr val="FF0000"/>
+              </a:solidFill>
+            </a:endParaRPr>
           </a:p>
         </p:txBody>
       </p:sp>
@@ -16004,6 +16064,36 @@
           </a:p>
         </p:txBody>
       </p:sp>
+      <p:pic>
+        <p:nvPicPr>
+          <p:cNvPr id="2" name="Picture 1">
+            <a:extLst>
+              <a:ext uri="{FF2B5EF4-FFF2-40B4-BE49-F238E27FC236}">
+                <a16:creationId xmlns:a16="http://schemas.microsoft.com/office/drawing/2014/main" id="{91ED6D32-502A-1757-7870-050DAE475D49}"/>
+              </a:ext>
+            </a:extLst>
+          </p:cNvPr>
+          <p:cNvPicPr>
+            <a:picLocks noChangeAspect="1"/>
+          </p:cNvPicPr>
+          <p:nvPr/>
+        </p:nvPicPr>
+        <p:blipFill>
+          <a:blip r:embed="rId4"/>
+          <a:stretch>
+            <a:fillRect/>
+          </a:stretch>
+        </p:blipFill>
+        <p:spPr>
+          <a:xfrm>
+            <a:off x="5368464" y="3546229"/>
+            <a:ext cx="6826657" cy="1286910"/>
+          </a:xfrm>
+          <a:prstGeom prst="rect">
+            <a:avLst/>
+          </a:prstGeom>
+        </p:spPr>
+      </p:pic>
     </p:spTree>
   </p:cSld>
   <p:clrMapOvr>
@@ -19910,6 +20000,36 @@
           </a:p>
         </p:txBody>
       </p:sp>
+      <p:pic>
+        <p:nvPicPr>
+          <p:cNvPr id="2" name="Picture 1">
+            <a:extLst>
+              <a:ext uri="{FF2B5EF4-FFF2-40B4-BE49-F238E27FC236}">
+                <a16:creationId xmlns:a16="http://schemas.microsoft.com/office/drawing/2014/main" id="{144A3A02-9FD2-E2AB-62B7-D7D69A46155C}"/>
+              </a:ext>
+            </a:extLst>
+          </p:cNvPr>
+          <p:cNvPicPr>
+            <a:picLocks noChangeAspect="1"/>
+          </p:cNvPicPr>
+          <p:nvPr/>
+        </p:nvPicPr>
+        <p:blipFill>
+          <a:blip r:embed="rId4"/>
+          <a:stretch>
+            <a:fillRect/>
+          </a:stretch>
+        </p:blipFill>
+        <p:spPr>
+          <a:xfrm>
+            <a:off x="571500" y="1328433"/>
+            <a:ext cx="6427763" cy="2361022"/>
+          </a:xfrm>
+          <a:prstGeom prst="rect">
+            <a:avLst/>
+          </a:prstGeom>
+        </p:spPr>
+      </p:pic>
     </p:spTree>
   </p:cSld>
   <p:clrMapOvr>
@@ -20508,6 +20628,36 @@
           </a:p>
         </p:txBody>
       </p:sp>
+      <p:pic>
+        <p:nvPicPr>
+          <p:cNvPr id="2" name="Picture 1">
+            <a:extLst>
+              <a:ext uri="{FF2B5EF4-FFF2-40B4-BE49-F238E27FC236}">
+                <a16:creationId xmlns:a16="http://schemas.microsoft.com/office/drawing/2014/main" id="{E02BFAED-6954-FCE8-79FF-0B151871DA12}"/>
+              </a:ext>
+            </a:extLst>
+          </p:cNvPr>
+          <p:cNvPicPr>
+            <a:picLocks noChangeAspect="1"/>
+          </p:cNvPicPr>
+          <p:nvPr/>
+        </p:nvPicPr>
+        <p:blipFill>
+          <a:blip r:embed="rId6"/>
+          <a:stretch>
+            <a:fillRect/>
+          </a:stretch>
+        </p:blipFill>
+        <p:spPr>
+          <a:xfrm>
+            <a:off x="5607050" y="183554"/>
+            <a:ext cx="6565900" cy="6299200"/>
+          </a:xfrm>
+          <a:prstGeom prst="rect">
+            <a:avLst/>
+          </a:prstGeom>
+        </p:spPr>
+      </p:pic>
     </p:spTree>
   </p:cSld>
   <p:clrMapOvr>
@@ -20625,7 +20775,13 @@
         <p:nvGraphicFramePr>
           <p:cNvPr id="317" name="Google Shape;317;p28"/>
           <p:cNvGraphicFramePr/>
-          <p:nvPr/>
+          <p:nvPr>
+            <p:extLst>
+              <p:ext uri="{D42A27DB-BD31-4B8C-83A1-F6EECF244321}">
+                <p14:modId xmlns:p14="http://schemas.microsoft.com/office/powerpoint/2010/main" val="2922709703"/>
+              </p:ext>
+            </p:extLst>
+          </p:nvPr>
         </p:nvGraphicFramePr>
         <p:xfrm>
           <a:off x="571500" y="3289994"/>
@@ -21084,7 +21240,7 @@
                         <a:buNone/>
                       </a:pPr>
                       <a:r>
-                        <a:rPr lang="en-US" sz="1200" b="0" i="0" u="none" strike="noStrike" cap="none">
+                        <a:rPr lang="en-US" sz="1200" b="0" i="0" u="none" strike="noStrike" cap="none" dirty="0">
                           <a:solidFill>
                             <a:srgbClr val="334155"/>
                           </a:solidFill>
@@ -21093,9 +21249,9 @@
                           <a:cs typeface="Lato"/>
                           <a:sym typeface="Lato"/>
                         </a:rPr>
-                        <a:t>-4.3</a:t>
+                        <a:t>-7.3</a:t>
                       </a:r>
-                      <a:endParaRPr/>
+                      <a:endParaRPr dirty="0"/>
                     </a:p>
                   </a:txBody>
                   <a:tcPr marL="63500" marR="63500" marT="25400" marB="25400" anchor="ctr">
@@ -21399,7 +21555,7 @@
                         <a:buNone/>
                       </a:pPr>
                       <a:r>
-                        <a:rPr lang="en-US" sz="1200" b="0" i="0" u="none" strike="noStrike" cap="none">
+                        <a:rPr lang="en-US" sz="1200" b="0" i="0" u="none" strike="noStrike" cap="none" dirty="0">
                           <a:solidFill>
                             <a:srgbClr val="334155"/>
                           </a:solidFill>
@@ -21408,9 +21564,9 @@
                           <a:cs typeface="Lato"/>
                           <a:sym typeface="Lato"/>
                         </a:rPr>
-                        <a:t>+4.3</a:t>
+                        <a:t>+1.9</a:t>
                       </a:r>
-                      <a:endParaRPr/>
+                      <a:endParaRPr dirty="0"/>
                     </a:p>
                   </a:txBody>
                   <a:tcPr marL="63500" marR="63500" marT="25400" marB="25400" anchor="ctr">
@@ -21714,7 +21870,7 @@
                         <a:buNone/>
                       </a:pPr>
                       <a:r>
-                        <a:rPr lang="en-US" sz="1200" b="0" i="0" u="none" strike="noStrike" cap="none">
+                        <a:rPr lang="en-US" sz="1200" b="0" i="0" u="none" strike="noStrike" cap="none" dirty="0">
                           <a:solidFill>
                             <a:srgbClr val="334155"/>
                           </a:solidFill>
@@ -21723,9 +21879,9 @@
                           <a:cs typeface="Lato"/>
                           <a:sym typeface="Lato"/>
                         </a:rPr>
-                        <a:t>+8.6</a:t>
+                        <a:t>+7.3</a:t>
                       </a:r>
-                      <a:endParaRPr/>
+                      <a:endParaRPr dirty="0"/>
                     </a:p>
                   </a:txBody>
                   <a:tcPr marL="63500" marR="63500" marT="25400" marB="25400" anchor="ctr">
@@ -21868,7 +22024,7 @@
                         <a:buNone/>
                       </a:pPr>
                       <a:r>
-                        <a:rPr lang="en-US" sz="1200" b="0" i="0" u="none" strike="noStrike" cap="none">
+                        <a:rPr lang="en-US" sz="1200" b="0" i="0" u="none" strike="noStrike" cap="none" dirty="0">
                           <a:solidFill>
                             <a:srgbClr val="334155"/>
                           </a:solidFill>
@@ -21879,7 +22035,7 @@
                         </a:rPr>
                         <a:t>Major discrepancy detected</a:t>
                       </a:r>
-                      <a:endParaRPr/>
+                      <a:endParaRPr dirty="0"/>
                     </a:p>
                   </a:txBody>
                   <a:tcPr marL="63500" marR="63500" marT="25400" marB="25400" anchor="ctr">
@@ -28342,33 +28498,6 @@
           </a:p>
         </p:txBody>
       </p:sp>
-      <p:pic>
-        <p:nvPicPr>
-          <p:cNvPr id="424" name="Google Shape;424;p34" descr="image.png"/>
-          <p:cNvPicPr preferRelativeResize="0"/>
-          <p:nvPr/>
-        </p:nvPicPr>
-        <p:blipFill rotWithShape="1">
-          <a:blip r:embed="rId5">
-            <a:alphaModFix/>
-          </a:blip>
-          <a:srcRect/>
-          <a:stretch/>
-        </p:blipFill>
-        <p:spPr>
-          <a:xfrm>
-            <a:off x="6334125" y="1843087"/>
-            <a:ext cx="5286375" cy="4286250"/>
-          </a:xfrm>
-          <a:prstGeom prst="rect">
-            <a:avLst/>
-          </a:prstGeom>
-          <a:noFill/>
-          <a:ln>
-            <a:noFill/>
-          </a:ln>
-        </p:spPr>
-      </p:pic>
       <p:sp>
         <p:nvSpPr>
           <p:cNvPr id="425" name="Google Shape;425;p34"/>
@@ -28467,6 +28596,36 @@
           </a:p>
         </p:txBody>
       </p:sp>
+      <p:pic>
+        <p:nvPicPr>
+          <p:cNvPr id="2" name="Picture 1">
+            <a:extLst>
+              <a:ext uri="{FF2B5EF4-FFF2-40B4-BE49-F238E27FC236}">
+                <a16:creationId xmlns:a16="http://schemas.microsoft.com/office/drawing/2014/main" id="{0EB31E16-6E78-A0A1-F547-8CD6B9D0A032}"/>
+              </a:ext>
+            </a:extLst>
+          </p:cNvPr>
+          <p:cNvPicPr>
+            <a:picLocks noChangeAspect="1"/>
+          </p:cNvPicPr>
+          <p:nvPr/>
+        </p:nvPicPr>
+        <p:blipFill>
+          <a:blip r:embed="rId5"/>
+          <a:stretch>
+            <a:fillRect/>
+          </a:stretch>
+        </p:blipFill>
+        <p:spPr>
+          <a:xfrm>
+            <a:off x="6260049" y="1353571"/>
+            <a:ext cx="5434525" cy="5392478"/>
+          </a:xfrm>
+          <a:prstGeom prst="rect">
+            <a:avLst/>
+          </a:prstGeom>
+        </p:spPr>
+      </p:pic>
     </p:spTree>
   </p:cSld>
   <p:clrMapOvr>
@@ -28949,10 +29108,16 @@
         <p:nvGraphicFramePr>
           <p:cNvPr id="445" name="Google Shape;445;p36"/>
           <p:cNvGraphicFramePr/>
-          <p:nvPr/>
+          <p:nvPr>
+            <p:extLst>
+              <p:ext uri="{D42A27DB-BD31-4B8C-83A1-F6EECF244321}">
+                <p14:modId xmlns:p14="http://schemas.microsoft.com/office/powerpoint/2010/main" val="2306615078"/>
+              </p:ext>
+            </p:extLst>
+          </p:nvPr>
         </p:nvGraphicFramePr>
         <p:xfrm>
-          <a:off x="571500" y="3941564"/>
+          <a:off x="155376" y="4504432"/>
           <a:ext cx="11039475" cy="2241925"/>
         </p:xfrm>
         <a:graphic>
@@ -29245,7 +29410,7 @@
                         <a:buNone/>
                       </a:pPr>
                       <a:r>
-                        <a:rPr lang="en-US" sz="1200" b="1" i="0" u="none" strike="noStrike" cap="none">
+                        <a:rPr lang="en-US" sz="1200" b="1" i="0" u="none" strike="noStrike" cap="none" dirty="0">
                           <a:solidFill>
                             <a:srgbClr val="334155"/>
                           </a:solidFill>
@@ -29256,7 +29421,7 @@
                         </a:rPr>
                         <a:t>Intercept</a:t>
                       </a:r>
-                      <a:endParaRPr/>
+                      <a:endParaRPr dirty="0"/>
                     </a:p>
                   </a:txBody>
                   <a:tcPr marL="63500" marR="63500" marT="25400" marB="25400" anchor="ctr">
@@ -29322,7 +29487,7 @@
                         <a:buNone/>
                       </a:pPr>
                       <a:r>
-                        <a:rPr lang="en-US" sz="1200" b="0" i="0" u="none" strike="noStrike" cap="none">
+                        <a:rPr lang="en-US" sz="1200" b="0" i="0" u="none" strike="noStrike" cap="none" dirty="0">
                           <a:solidFill>
                             <a:srgbClr val="334155"/>
                           </a:solidFill>
@@ -29331,9 +29496,21 @@
                           <a:cs typeface="Lato"/>
                           <a:sym typeface="Lato"/>
                         </a:rPr>
-                        <a:t>0.052</a:t>
+                        <a:t>0.0</a:t>
                       </a:r>
-                      <a:endParaRPr/>
+                      <a:r>
+                        <a:rPr lang="en-US" altLang="zh-CN" sz="1200" b="0" i="0" u="none" strike="noStrike" cap="none" dirty="0">
+                          <a:solidFill>
+                            <a:srgbClr val="334155"/>
+                          </a:solidFill>
+                          <a:latin typeface="Lato"/>
+                          <a:ea typeface="Lato"/>
+                          <a:cs typeface="Lato"/>
+                          <a:sym typeface="Lato"/>
+                        </a:rPr>
+                        <a:t>7</a:t>
+                      </a:r>
+                      <a:endParaRPr dirty="0"/>
                     </a:p>
                   </a:txBody>
                   <a:tcPr marL="63500" marR="63500" marT="25400" marB="25400" anchor="ctr">
@@ -29560,7 +29737,7 @@
                         <a:buNone/>
                       </a:pPr>
                       <a:r>
-                        <a:rPr lang="en-US" sz="1200" b="0" i="0" u="none" strike="noStrike" cap="none">
+                        <a:rPr lang="en-US" sz="1200" b="0" i="0" u="none" strike="noStrike" cap="none" dirty="0">
                           <a:solidFill>
                             <a:srgbClr val="334155"/>
                           </a:solidFill>
@@ -29569,9 +29746,21 @@
                           <a:cs typeface="Lato"/>
                           <a:sym typeface="Lato"/>
                         </a:rPr>
-                        <a:t>0.00872</a:t>
+                        <a:t>0.008</a:t>
                       </a:r>
-                      <a:endParaRPr/>
+                      <a:r>
+                        <a:rPr lang="en-US" altLang="zh-CN" sz="1200" b="0" i="0" u="none" strike="noStrike" cap="none" dirty="0">
+                          <a:solidFill>
+                            <a:srgbClr val="334155"/>
+                          </a:solidFill>
+                          <a:latin typeface="Lato"/>
+                          <a:ea typeface="Lato"/>
+                          <a:cs typeface="Lato"/>
+                          <a:sym typeface="Lato"/>
+                        </a:rPr>
+                        <a:t>535</a:t>
+                      </a:r>
+                      <a:endParaRPr dirty="0"/>
                     </a:p>
                   </a:txBody>
                   <a:tcPr marL="63500" marR="63500" marT="25400" marB="25400" anchor="ctr">
@@ -29798,7 +29987,7 @@
                         <a:buNone/>
                       </a:pPr>
                       <a:r>
-                        <a:rPr lang="en-US" sz="1200" b="0" i="0" u="none" strike="noStrike" cap="none">
+                        <a:rPr lang="en-US" sz="1200" b="0" i="0" u="none" strike="noStrike" cap="none" dirty="0">
                           <a:solidFill>
                             <a:srgbClr val="334155"/>
                           </a:solidFill>
@@ -29807,9 +29996,9 @@
                           <a:cs typeface="Lato"/>
                           <a:sym typeface="Lato"/>
                         </a:rPr>
-                        <a:t>0.9987</a:t>
+                        <a:t>0.998</a:t>
                       </a:r>
-                      <a:endParaRPr/>
+                      <a:endParaRPr dirty="0"/>
                     </a:p>
                   </a:txBody>
                   <a:tcPr marL="63500" marR="63500" marT="25400" marB="25400" anchor="ctr">
@@ -29875,7 +30064,7 @@
                         <a:buNone/>
                       </a:pPr>
                       <a:r>
-                        <a:rPr lang="en-US" sz="1200" b="0" i="0" u="none" strike="noStrike" cap="none">
+                        <a:rPr lang="en-US" sz="1200" b="0" i="0" u="none" strike="noStrike" cap="none" dirty="0">
                           <a:solidFill>
                             <a:srgbClr val="334155"/>
                           </a:solidFill>
@@ -29884,9 +30073,9 @@
                           <a:cs typeface="Lato"/>
                           <a:sym typeface="Lato"/>
                         </a:rPr>
-                        <a:t>99.87% of the variance is explained by the model.</a:t>
+                        <a:t>99.8% of the variance is explained by the model.</a:t>
                       </a:r>
-                      <a:endParaRPr/>
+                      <a:endParaRPr dirty="0"/>
                     </a:p>
                   </a:txBody>
                   <a:tcPr marL="63500" marR="63500" marT="25400" marB="25400" anchor="ctr">
@@ -30381,56 +30570,6 @@
       </p:sp>
       <p:sp>
         <p:nvSpPr>
-          <p:cNvPr id="455" name="Google Shape;455;p36"/>
-          <p:cNvSpPr txBox="1"/>
-          <p:nvPr/>
-        </p:nvSpPr>
-        <p:spPr>
-          <a:xfrm>
-            <a:off x="571500" y="571500"/>
-            <a:ext cx="11601450" cy="590550"/>
-          </a:xfrm>
-          <a:prstGeom prst="rect">
-            <a:avLst/>
-          </a:prstGeom>
-          <a:noFill/>
-          <a:ln>
-            <a:noFill/>
-          </a:ln>
-        </p:spPr>
-        <p:txBody>
-          <a:bodyPr spcFirstLastPara="1" wrap="square" lIns="0" tIns="0" rIns="0" bIns="0" anchor="t" anchorCtr="0">
-            <a:spAutoFit/>
-          </a:bodyPr>
-          <a:lstStyle/>
-          <a:p>
-            <a:pPr marL="0" marR="0" lvl="0" indent="0" algn="l" rtl="0">
-              <a:spcBef>
-                <a:spcPts val="0"/>
-              </a:spcBef>
-              <a:spcAft>
-                <a:spcPts val="0"/>
-              </a:spcAft>
-              <a:buNone/>
-            </a:pPr>
-            <a:r>
-              <a:rPr lang="en-US" sz="3600" b="1" i="0" u="none" strike="noStrike" cap="none">
-                <a:solidFill>
-                  <a:srgbClr val="1E3A8A"/>
-                </a:solidFill>
-                <a:latin typeface="Merriweather"/>
-                <a:ea typeface="Merriweather"/>
-                <a:cs typeface="Merriweather"/>
-                <a:sym typeface="Merriweather"/>
-              </a:rPr>
-              <a:t>Interpreting lm() Output</a:t>
-            </a:r>
-            <a:endParaRPr/>
-          </a:p>
-        </p:txBody>
-      </p:sp>
-      <p:sp>
-        <p:nvSpPr>
           <p:cNvPr id="456" name="Google Shape;456;p36"/>
           <p:cNvSpPr/>
           <p:nvPr/>
@@ -30474,6 +30613,110 @@
               <a:cs typeface="Calibri"/>
               <a:sym typeface="Calibri"/>
             </a:endParaRPr>
+          </a:p>
+        </p:txBody>
+      </p:sp>
+      <p:pic>
+        <p:nvPicPr>
+          <p:cNvPr id="2" name="Picture 1">
+            <a:extLst>
+              <a:ext uri="{FF2B5EF4-FFF2-40B4-BE49-F238E27FC236}">
+                <a16:creationId xmlns:a16="http://schemas.microsoft.com/office/drawing/2014/main" id="{3B0B46FD-D3C6-81CD-E85A-7D4130690523}"/>
+              </a:ext>
+            </a:extLst>
+          </p:cNvPr>
+          <p:cNvPicPr>
+            <a:picLocks noChangeAspect="1"/>
+          </p:cNvPicPr>
+          <p:nvPr/>
+        </p:nvPicPr>
+        <p:blipFill>
+          <a:blip r:embed="rId4"/>
+          <a:stretch>
+            <a:fillRect/>
+          </a:stretch>
+        </p:blipFill>
+        <p:spPr>
+          <a:xfrm>
+            <a:off x="155376" y="118448"/>
+            <a:ext cx="7772400" cy="4381221"/>
+          </a:xfrm>
+          <a:prstGeom prst="rect">
+            <a:avLst/>
+          </a:prstGeom>
+        </p:spPr>
+      </p:pic>
+      <p:sp>
+        <p:nvSpPr>
+          <p:cNvPr id="455" name="Google Shape;455;p36"/>
+          <p:cNvSpPr txBox="1"/>
+          <p:nvPr/>
+        </p:nvSpPr>
+        <p:spPr>
+          <a:xfrm>
+            <a:off x="6222271" y="1027926"/>
+            <a:ext cx="5814353" cy="553998"/>
+          </a:xfrm>
+          <a:prstGeom prst="rect">
+            <a:avLst/>
+          </a:prstGeom>
+          <a:noFill/>
+          <a:ln>
+            <a:noFill/>
+          </a:ln>
+        </p:spPr>
+        <p:txBody>
+          <a:bodyPr spcFirstLastPara="1" wrap="square" lIns="0" tIns="0" rIns="0" bIns="0" anchor="t" anchorCtr="0">
+            <a:spAutoFit/>
+          </a:bodyPr>
+          <a:lstStyle/>
+          <a:p>
+            <a:pPr marL="0" marR="0" lvl="0" indent="0" algn="l" rtl="0">
+              <a:spcBef>
+                <a:spcPts val="0"/>
+              </a:spcBef>
+              <a:spcAft>
+                <a:spcPts val="0"/>
+              </a:spcAft>
+              <a:buNone/>
+            </a:pPr>
+            <a:r>
+              <a:rPr lang="en-US" sz="3600" b="1" i="0" u="none" strike="noStrike" cap="none" dirty="0">
+                <a:solidFill>
+                  <a:srgbClr val="1E3A8A"/>
+                </a:solidFill>
+                <a:latin typeface="Merriweather"/>
+                <a:ea typeface="Merriweather"/>
+                <a:cs typeface="Merriweather"/>
+                <a:sym typeface="Merriweather"/>
+              </a:rPr>
+              <a:t>Interpreting </a:t>
+            </a:r>
+            <a:r>
+              <a:rPr lang="en-US" sz="3600" b="1" i="0" u="none" strike="noStrike" cap="none" dirty="0" err="1">
+                <a:solidFill>
+                  <a:srgbClr val="1E3A8A"/>
+                </a:solidFill>
+                <a:latin typeface="Merriweather"/>
+                <a:ea typeface="Merriweather"/>
+                <a:cs typeface="Merriweather"/>
+                <a:sym typeface="Merriweather"/>
+              </a:rPr>
+              <a:t>lm</a:t>
+            </a:r>
+            <a:r>
+              <a:rPr lang="en-US" sz="3600" b="1" i="0" u="none" strike="noStrike" cap="none" dirty="0">
+                <a:solidFill>
+                  <a:srgbClr val="1E3A8A"/>
+                </a:solidFill>
+                <a:latin typeface="Merriweather"/>
+                <a:ea typeface="Merriweather"/>
+                <a:cs typeface="Merriweather"/>
+                <a:sym typeface="Merriweather"/>
+              </a:rPr>
+              <a:t>() Output</a:t>
+            </a:r>
+            <a:endParaRPr dirty="0"/>
           </a:p>
         </p:txBody>
       </p:sp>
@@ -30679,7 +30922,7 @@
               <a:buNone/>
             </a:pPr>
             <a:r>
-              <a:rPr lang="en-US" sz="1800" b="1" i="0" u="none" strike="noStrike" cap="none">
+              <a:rPr lang="en-US" sz="1800" b="1" i="0" u="none" strike="noStrike" cap="none" dirty="0">
                 <a:solidFill>
                   <a:srgbClr val="334155"/>
                 </a:solidFill>
@@ -30690,37 +30933,10 @@
               </a:rPr>
               <a:t>Final Calibration Equation:</a:t>
             </a:r>
-            <a:endParaRPr/>
+            <a:endParaRPr dirty="0"/>
           </a:p>
         </p:txBody>
       </p:sp>
-      <p:pic>
-        <p:nvPicPr>
-          <p:cNvPr id="466" name="Google Shape;466;p37" descr="image.png"/>
-          <p:cNvPicPr preferRelativeResize="0"/>
-          <p:nvPr/>
-        </p:nvPicPr>
-        <p:blipFill rotWithShape="1">
-          <a:blip r:embed="rId6">
-            <a:alphaModFix/>
-          </a:blip>
-          <a:srcRect/>
-          <a:stretch/>
-        </p:blipFill>
-        <p:spPr>
-          <a:xfrm>
-            <a:off x="6629400" y="4221360"/>
-            <a:ext cx="4695825" cy="238125"/>
-          </a:xfrm>
-          <a:prstGeom prst="rect">
-            <a:avLst/>
-          </a:prstGeom>
-          <a:noFill/>
-          <a:ln>
-            <a:noFill/>
-          </a:ln>
-        </p:spPr>
-      </p:pic>
       <p:sp>
         <p:nvSpPr>
           <p:cNvPr id="467" name="Google Shape;467;p37"/>
@@ -30816,6 +31032,204 @@
               <a:cs typeface="Calibri"/>
               <a:sym typeface="Calibri"/>
             </a:endParaRPr>
+          </a:p>
+        </p:txBody>
+      </p:sp>
+      <p:sp>
+        <p:nvSpPr>
+          <p:cNvPr id="3" name="TextBox 2">
+            <a:extLst>
+              <a:ext uri="{FF2B5EF4-FFF2-40B4-BE49-F238E27FC236}">
+                <a16:creationId xmlns:a16="http://schemas.microsoft.com/office/drawing/2014/main" id="{1CE2786B-FA5B-400C-5EC1-AC9CB31FB2EA}"/>
+              </a:ext>
+            </a:extLst>
+          </p:cNvPr>
+          <p:cNvSpPr txBox="1"/>
+          <p:nvPr/>
+        </p:nvSpPr>
+        <p:spPr>
+          <a:xfrm>
+            <a:off x="6805246" y="4187480"/>
+            <a:ext cx="6210886" cy="307777"/>
+          </a:xfrm>
+          <a:prstGeom prst="rect">
+            <a:avLst/>
+          </a:prstGeom>
+          <a:noFill/>
+        </p:spPr>
+        <p:txBody>
+          <a:bodyPr wrap="square">
+            <a:spAutoFit/>
+          </a:bodyPr>
+          <a:lstStyle/>
+          <a:p>
+            <a:r>
+              <a:rPr lang="en-US" b="1" i="0" dirty="0">
+                <a:solidFill>
+                  <a:srgbClr val="1F1F1F"/>
+                </a:solidFill>
+                <a:effectLst/>
+                <a:latin typeface="Courier New" panose="02070309020205020404" pitchFamily="49" charset="0"/>
+              </a:rPr>
+              <a:t>Signal = 0.0085 × Concentration + 0.0709</a:t>
+            </a:r>
+            <a:endParaRPr lang="en-US" b="1" dirty="0"/>
+          </a:p>
+        </p:txBody>
+      </p:sp>
+      <p:sp>
+        <p:nvSpPr>
+          <p:cNvPr id="4" name="Rectangle 3">
+            <a:extLst>
+              <a:ext uri="{FF2B5EF4-FFF2-40B4-BE49-F238E27FC236}">
+                <a16:creationId xmlns:a16="http://schemas.microsoft.com/office/drawing/2014/main" id="{BF23984E-5693-20BC-DA67-5581CAB16EB7}"/>
+              </a:ext>
+            </a:extLst>
+          </p:cNvPr>
+          <p:cNvSpPr/>
+          <p:nvPr/>
+        </p:nvSpPr>
+        <p:spPr>
+          <a:xfrm>
+            <a:off x="986570" y="3547987"/>
+            <a:ext cx="2228117" cy="193403"/>
+          </a:xfrm>
+          <a:prstGeom prst="rect">
+            <a:avLst/>
+          </a:prstGeom>
+          <a:solidFill>
+            <a:schemeClr val="bg1"/>
+          </a:solidFill>
+          <a:ln>
+            <a:noFill/>
+          </a:ln>
+        </p:spPr>
+        <p:style>
+          <a:lnRef idx="2">
+            <a:schemeClr val="accent1">
+              <a:shade val="15000"/>
+            </a:schemeClr>
+          </a:lnRef>
+          <a:fillRef idx="1">
+            <a:schemeClr val="accent1"/>
+          </a:fillRef>
+          <a:effectRef idx="0">
+            <a:schemeClr val="accent1"/>
+          </a:effectRef>
+          <a:fontRef idx="minor">
+            <a:schemeClr val="lt1"/>
+          </a:fontRef>
+        </p:style>
+        <p:txBody>
+          <a:bodyPr rtlCol="0" anchor="ctr"/>
+          <a:lstStyle/>
+          <a:p>
+            <a:pPr algn="ctr"/>
+            <a:endParaRPr lang="en-US"/>
+          </a:p>
+        </p:txBody>
+      </p:sp>
+      <p:sp>
+        <p:nvSpPr>
+          <p:cNvPr id="5" name="Rectangle 4">
+            <a:extLst>
+              <a:ext uri="{FF2B5EF4-FFF2-40B4-BE49-F238E27FC236}">
+                <a16:creationId xmlns:a16="http://schemas.microsoft.com/office/drawing/2014/main" id="{510C2EE6-8935-EE1B-73B4-F32B6DD10CC7}"/>
+              </a:ext>
+            </a:extLst>
+          </p:cNvPr>
+          <p:cNvSpPr/>
+          <p:nvPr/>
+        </p:nvSpPr>
+        <p:spPr>
+          <a:xfrm>
+            <a:off x="986569" y="4198896"/>
+            <a:ext cx="2228117" cy="193403"/>
+          </a:xfrm>
+          <a:prstGeom prst="rect">
+            <a:avLst/>
+          </a:prstGeom>
+          <a:solidFill>
+            <a:schemeClr val="bg1"/>
+          </a:solidFill>
+          <a:ln>
+            <a:noFill/>
+          </a:ln>
+        </p:spPr>
+        <p:style>
+          <a:lnRef idx="2">
+            <a:schemeClr val="accent1">
+              <a:shade val="15000"/>
+            </a:schemeClr>
+          </a:lnRef>
+          <a:fillRef idx="1">
+            <a:schemeClr val="accent1"/>
+          </a:fillRef>
+          <a:effectRef idx="0">
+            <a:schemeClr val="accent1"/>
+          </a:effectRef>
+          <a:fontRef idx="minor">
+            <a:schemeClr val="lt1"/>
+          </a:fontRef>
+        </p:style>
+        <p:txBody>
+          <a:bodyPr rtlCol="0" anchor="ctr"/>
+          <a:lstStyle/>
+          <a:p>
+            <a:pPr algn="ctr"/>
+            <a:endParaRPr lang="en-US"/>
+          </a:p>
+        </p:txBody>
+      </p:sp>
+      <p:sp>
+        <p:nvSpPr>
+          <p:cNvPr id="6" name="Rectangle 5">
+            <a:extLst>
+              <a:ext uri="{FF2B5EF4-FFF2-40B4-BE49-F238E27FC236}">
+                <a16:creationId xmlns:a16="http://schemas.microsoft.com/office/drawing/2014/main" id="{9BB58B91-D3A5-8D7C-D830-B689A2F2FD29}"/>
+              </a:ext>
+            </a:extLst>
+          </p:cNvPr>
+          <p:cNvSpPr/>
+          <p:nvPr/>
+        </p:nvSpPr>
+        <p:spPr>
+          <a:xfrm>
+            <a:off x="986569" y="4952185"/>
+            <a:ext cx="2228117" cy="193403"/>
+          </a:xfrm>
+          <a:prstGeom prst="rect">
+            <a:avLst/>
+          </a:prstGeom>
+          <a:solidFill>
+            <a:schemeClr val="bg1"/>
+          </a:solidFill>
+          <a:ln>
+            <a:noFill/>
+          </a:ln>
+        </p:spPr>
+        <p:style>
+          <a:lnRef idx="2">
+            <a:schemeClr val="accent1">
+              <a:shade val="15000"/>
+            </a:schemeClr>
+          </a:lnRef>
+          <a:fillRef idx="1">
+            <a:schemeClr val="accent1"/>
+          </a:fillRef>
+          <a:effectRef idx="0">
+            <a:schemeClr val="accent1"/>
+          </a:effectRef>
+          <a:fontRef idx="minor">
+            <a:schemeClr val="lt1"/>
+          </a:fontRef>
+        </p:style>
+        <p:txBody>
+          <a:bodyPr rtlCol="0" anchor="ctr"/>
+          <a:lstStyle/>
+          <a:p>
+            <a:pPr algn="ctr"/>
+            <a:endParaRPr lang="en-US"/>
           </a:p>
         </p:txBody>
       </p:sp>
@@ -30959,33 +31373,6 @@
           </a:p>
         </p:txBody>
       </p:sp>
-      <p:pic>
-        <p:nvPicPr>
-          <p:cNvPr id="476" name="Google Shape;476;p38" descr="image.png"/>
-          <p:cNvPicPr preferRelativeResize="0"/>
-          <p:nvPr/>
-        </p:nvPicPr>
-        <p:blipFill rotWithShape="1">
-          <a:blip r:embed="rId5">
-            <a:alphaModFix/>
-          </a:blip>
-          <a:srcRect/>
-          <a:stretch/>
-        </p:blipFill>
-        <p:spPr>
-          <a:xfrm>
-            <a:off x="6334125" y="1843087"/>
-            <a:ext cx="5286375" cy="4286250"/>
-          </a:xfrm>
-          <a:prstGeom prst="rect">
-            <a:avLst/>
-          </a:prstGeom>
-          <a:noFill/>
-          <a:ln>
-            <a:noFill/>
-          </a:ln>
-        </p:spPr>
-      </p:pic>
       <p:sp>
         <p:nvSpPr>
           <p:cNvPr id="477" name="Google Shape;477;p38"/>
@@ -31084,6 +31471,36 @@
           </a:p>
         </p:txBody>
       </p:sp>
+      <p:pic>
+        <p:nvPicPr>
+          <p:cNvPr id="2" name="Picture 1">
+            <a:extLst>
+              <a:ext uri="{FF2B5EF4-FFF2-40B4-BE49-F238E27FC236}">
+                <a16:creationId xmlns:a16="http://schemas.microsoft.com/office/drawing/2014/main" id="{F5A64917-325A-4618-925C-CF0842F0F322}"/>
+              </a:ext>
+            </a:extLst>
+          </p:cNvPr>
+          <p:cNvPicPr>
+            <a:picLocks noChangeAspect="1"/>
+          </p:cNvPicPr>
+          <p:nvPr/>
+        </p:nvPicPr>
+        <p:blipFill>
+          <a:blip r:embed="rId5"/>
+          <a:stretch>
+            <a:fillRect/>
+          </a:stretch>
+        </p:blipFill>
+        <p:spPr>
+          <a:xfrm>
+            <a:off x="6334125" y="1317191"/>
+            <a:ext cx="5638752" cy="5552664"/>
+          </a:xfrm>
+          <a:prstGeom prst="rect">
+            <a:avLst/>
+          </a:prstGeom>
+        </p:spPr>
+      </p:pic>
     </p:spTree>
   </p:cSld>
   <p:clrMapOvr>
@@ -36230,6 +36647,58 @@
               <a:cs typeface="Calibri"/>
               <a:sym typeface="Calibri"/>
             </a:endParaRPr>
+          </a:p>
+        </p:txBody>
+      </p:sp>
+      <p:sp>
+        <p:nvSpPr>
+          <p:cNvPr id="2" name="Rectangle 1">
+            <a:extLst>
+              <a:ext uri="{FF2B5EF4-FFF2-40B4-BE49-F238E27FC236}">
+                <a16:creationId xmlns:a16="http://schemas.microsoft.com/office/drawing/2014/main" id="{7D3EE85F-4F3A-732A-9C37-895CB7AFA0F0}"/>
+              </a:ext>
+            </a:extLst>
+          </p:cNvPr>
+          <p:cNvSpPr/>
+          <p:nvPr/>
+        </p:nvSpPr>
+        <p:spPr>
+          <a:xfrm>
+            <a:off x="6805467" y="4701538"/>
+            <a:ext cx="2228117" cy="193403"/>
+          </a:xfrm>
+          <a:prstGeom prst="rect">
+            <a:avLst/>
+          </a:prstGeom>
+          <a:solidFill>
+            <a:schemeClr val="bg1"/>
+          </a:solidFill>
+          <a:ln>
+            <a:noFill/>
+          </a:ln>
+        </p:spPr>
+        <p:style>
+          <a:lnRef idx="2">
+            <a:schemeClr val="accent1">
+              <a:shade val="15000"/>
+            </a:schemeClr>
+          </a:lnRef>
+          <a:fillRef idx="1">
+            <a:schemeClr val="accent1"/>
+          </a:fillRef>
+          <a:effectRef idx="0">
+            <a:schemeClr val="accent1"/>
+          </a:effectRef>
+          <a:fontRef idx="minor">
+            <a:schemeClr val="lt1"/>
+          </a:fontRef>
+        </p:style>
+        <p:txBody>
+          <a:bodyPr rtlCol="0" anchor="ctr"/>
+          <a:lstStyle/>
+          <a:p>
+            <a:pPr algn="ctr"/>
+            <a:endParaRPr lang="en-US"/>
           </a:p>
         </p:txBody>
       </p:sp>
@@ -48835,7 +49304,13 @@
         <p:nvGraphicFramePr>
           <p:cNvPr id="174" name="Google Shape;174;p18"/>
           <p:cNvGraphicFramePr/>
-          <p:nvPr/>
+          <p:nvPr>
+            <p:extLst>
+              <p:ext uri="{D42A27DB-BD31-4B8C-83A1-F6EECF244321}">
+                <p14:modId xmlns:p14="http://schemas.microsoft.com/office/powerpoint/2010/main" val="3222171675"/>
+              </p:ext>
+            </p:extLst>
+          </p:nvPr>
         </p:nvGraphicFramePr>
         <p:xfrm>
           <a:off x="6629400" y="3150989"/>
@@ -48966,7 +49441,7 @@
                         <a:buNone/>
                       </a:pPr>
                       <a:r>
-                        <a:rPr lang="en-US" sz="1200" b="1" i="0" u="none" strike="noStrike" cap="none">
+                        <a:rPr lang="en-US" sz="1200" b="1" i="0" u="none" strike="noStrike" cap="none" dirty="0">
                           <a:solidFill>
                             <a:srgbClr val="334155"/>
                           </a:solidFill>
@@ -48977,7 +49452,7 @@
                         </a:rPr>
                         <a:t>Mean Glucose</a:t>
                       </a:r>
-                      <a:endParaRPr/>
+                      <a:endParaRPr dirty="0"/>
                     </a:p>
                   </a:txBody>
                   <a:tcPr marL="63500" marR="63500" marT="25400" marB="25400" anchor="ctr">
@@ -49045,7 +49520,7 @@
                         <a:buNone/>
                       </a:pPr>
                       <a:r>
-                        <a:rPr lang="en-US" sz="1200" b="1" i="0" u="none" strike="noStrike" cap="none">
+                        <a:rPr lang="en-US" sz="1200" b="1" i="0" u="none" strike="noStrike" cap="none" dirty="0">
                           <a:solidFill>
                             <a:srgbClr val="334155"/>
                           </a:solidFill>
@@ -49056,7 +49531,7 @@
                         </a:rPr>
                         <a:t>SD</a:t>
                       </a:r>
-                      <a:endParaRPr/>
+                      <a:endParaRPr dirty="0"/>
                     </a:p>
                   </a:txBody>
                   <a:tcPr marL="63500" marR="63500" marT="25400" marB="25400" anchor="ctr">
@@ -49131,7 +49606,7 @@
                         <a:buNone/>
                       </a:pPr>
                       <a:r>
-                        <a:rPr lang="en-US" sz="1200" b="0" i="0" u="none" strike="noStrike" cap="none">
+                        <a:rPr lang="en-US" sz="1200" b="0" i="0" u="none" strike="noStrike" cap="none" dirty="0">
                           <a:solidFill>
                             <a:srgbClr val="334155"/>
                           </a:solidFill>
@@ -49142,7 +49617,7 @@
                         </a:rPr>
                         <a:t>A</a:t>
                       </a:r>
-                      <a:endParaRPr/>
+                      <a:endParaRPr dirty="0"/>
                     </a:p>
                   </a:txBody>
                   <a:tcPr marL="63500" marR="63500" marT="25400" marB="25400" anchor="ctr">
@@ -49208,7 +49683,7 @@
                         <a:buNone/>
                       </a:pPr>
                       <a:r>
-                        <a:rPr lang="en-US" sz="1200" b="0" i="0" u="none" strike="noStrike" cap="none">
+                        <a:rPr lang="en-US" sz="1200" b="0" i="0" u="none" strike="noStrike" cap="none" dirty="0">
                           <a:solidFill>
                             <a:srgbClr val="334155"/>
                           </a:solidFill>
@@ -49217,9 +49692,9 @@
                           <a:cs typeface="Lato"/>
                           <a:sym typeface="Lato"/>
                         </a:rPr>
-                        <a:t>102.5</a:t>
+                        <a:t>102.3</a:t>
                       </a:r>
-                      <a:endParaRPr/>
+                      <a:endParaRPr dirty="0"/>
                     </a:p>
                   </a:txBody>
                   <a:tcPr marL="63500" marR="63500" marT="25400" marB="25400" anchor="ctr">
@@ -49285,7 +49760,7 @@
                         <a:buNone/>
                       </a:pPr>
                       <a:r>
-                        <a:rPr lang="en-US" sz="1200" b="0" i="0" u="none" strike="noStrike" cap="none">
+                        <a:rPr lang="en-US" sz="1200" b="0" i="0" u="none" strike="noStrike" cap="none" dirty="0">
                           <a:solidFill>
                             <a:srgbClr val="334155"/>
                           </a:solidFill>
@@ -49294,9 +49769,9 @@
                           <a:cs typeface="Lato"/>
                           <a:sym typeface="Lato"/>
                         </a:rPr>
-                        <a:t>1.5</a:t>
+                        <a:t>1.4</a:t>
                       </a:r>
-                      <a:endParaRPr/>
+                      <a:endParaRPr dirty="0"/>
                     </a:p>
                   </a:txBody>
                   <a:tcPr marL="63500" marR="63500" marT="25400" marB="25400" anchor="ctr">
@@ -49446,7 +49921,7 @@
                         <a:buNone/>
                       </a:pPr>
                       <a:r>
-                        <a:rPr lang="en-US" sz="1200" b="0" i="0" u="none" strike="noStrike" cap="none">
+                        <a:rPr lang="en-US" sz="1200" b="0" i="0" u="none" strike="noStrike" cap="none" dirty="0">
                           <a:solidFill>
                             <a:srgbClr val="334155"/>
                           </a:solidFill>
@@ -49455,9 +49930,9 @@
                           <a:cs typeface="Lato"/>
                           <a:sym typeface="Lato"/>
                         </a:rPr>
-                        <a:t>98.2</a:t>
+                        <a:t>96.9</a:t>
                       </a:r>
-                      <a:endParaRPr/>
+                      <a:endParaRPr dirty="0"/>
                     </a:p>
                   </a:txBody>
                   <a:tcPr marL="63500" marR="63500" marT="25400" marB="25400" anchor="ctr">
@@ -49523,7 +49998,7 @@
                         <a:buNone/>
                       </a:pPr>
                       <a:r>
-                        <a:rPr lang="en-US" sz="1200" b="0" i="0" u="none" strike="noStrike" cap="none">
+                        <a:rPr lang="en-US" sz="1200" b="0" i="0" u="none" strike="noStrike" cap="none" dirty="0">
                           <a:solidFill>
                             <a:srgbClr val="334155"/>
                           </a:solidFill>
@@ -49532,9 +50007,9 @@
                           <a:cs typeface="Lato"/>
                           <a:sym typeface="Lato"/>
                         </a:rPr>
-                        <a:t>1.4</a:t>
+                        <a:t>2.1</a:t>
                       </a:r>
-                      <a:endParaRPr/>
+                      <a:endParaRPr dirty="0"/>
                     </a:p>
                   </a:txBody>
                   <a:tcPr marL="63500" marR="63500" marT="25400" marB="25400" anchor="ctr">
@@ -49684,7 +50159,7 @@
                         <a:buNone/>
                       </a:pPr>
                       <a:r>
-                        <a:rPr lang="en-US" sz="1200" b="0" i="0" u="none" strike="noStrike" cap="none">
+                        <a:rPr lang="en-US" sz="1200" b="0" i="0" u="none" strike="noStrike" cap="none" dirty="0">
                           <a:solidFill>
                             <a:srgbClr val="334155"/>
                           </a:solidFill>
@@ -49693,9 +50168,9 @@
                           <a:cs typeface="Lato"/>
                           <a:sym typeface="Lato"/>
                         </a:rPr>
-                        <a:t>106.8</a:t>
+                        <a:t>106.1</a:t>
                       </a:r>
-                      <a:endParaRPr/>
+                      <a:endParaRPr dirty="0"/>
                     </a:p>
                   </a:txBody>
                   <a:tcPr marL="63500" marR="63500" marT="25400" marB="25400" anchor="ctr">
@@ -49761,7 +50236,7 @@
                         <a:buNone/>
                       </a:pPr>
                       <a:r>
-                        <a:rPr lang="en-US" sz="1200" b="0" i="0" u="none" strike="noStrike" cap="none">
+                        <a:rPr lang="en-US" sz="1200" b="0" i="0" u="none" strike="noStrike" cap="none" dirty="0">
                           <a:solidFill>
                             <a:srgbClr val="334155"/>
                           </a:solidFill>
@@ -49772,7 +50247,7 @@
                         </a:rPr>
                         <a:t>1.6</a:t>
                       </a:r>
-                      <a:endParaRPr/>
+                      <a:endParaRPr dirty="0"/>
                     </a:p>
                   </a:txBody>
                   <a:tcPr marL="63500" marR="63500" marT="25400" marB="25400" anchor="ctr">
@@ -50515,33 +50990,6 @@
           </a:p>
         </p:txBody>
       </p:sp>
-      <p:pic>
-        <p:nvPicPr>
-          <p:cNvPr id="193" name="Google Shape;193;p19" descr="image.png"/>
-          <p:cNvPicPr preferRelativeResize="0"/>
-          <p:nvPr/>
-        </p:nvPicPr>
-        <p:blipFill rotWithShape="1">
-          <a:blip r:embed="rId5">
-            <a:alphaModFix/>
-          </a:blip>
-          <a:srcRect/>
-          <a:stretch/>
-        </p:blipFill>
-        <p:spPr>
-          <a:xfrm>
-            <a:off x="6334125" y="1843087"/>
-            <a:ext cx="5286375" cy="4286250"/>
-          </a:xfrm>
-          <a:prstGeom prst="rect">
-            <a:avLst/>
-          </a:prstGeom>
-          <a:noFill/>
-          <a:ln>
-            <a:noFill/>
-          </a:ln>
-        </p:spPr>
-      </p:pic>
       <p:sp>
         <p:nvSpPr>
           <p:cNvPr id="194" name="Google Shape;194;p19"/>
@@ -50640,6 +51088,36 @@
           </a:p>
         </p:txBody>
       </p:sp>
+      <p:pic>
+        <p:nvPicPr>
+          <p:cNvPr id="3" name="Picture 2">
+            <a:extLst>
+              <a:ext uri="{FF2B5EF4-FFF2-40B4-BE49-F238E27FC236}">
+                <a16:creationId xmlns:a16="http://schemas.microsoft.com/office/drawing/2014/main" id="{215665B6-5B9D-1021-194D-34C2D922C939}"/>
+              </a:ext>
+            </a:extLst>
+          </p:cNvPr>
+          <p:cNvPicPr>
+            <a:picLocks noChangeAspect="1"/>
+          </p:cNvPicPr>
+          <p:nvPr/>
+        </p:nvPicPr>
+        <p:blipFill>
+          <a:blip r:embed="rId5"/>
+          <a:stretch>
+            <a:fillRect/>
+          </a:stretch>
+        </p:blipFill>
+        <p:spPr>
+          <a:xfrm>
+            <a:off x="6097062" y="1162050"/>
+            <a:ext cx="5760500" cy="5542299"/>
+          </a:xfrm>
+          <a:prstGeom prst="rect">
+            <a:avLst/>
+          </a:prstGeom>
+        </p:spPr>
+      </p:pic>
     </p:spTree>
   </p:cSld>
   <p:clrMapOvr>

</xml_diff>